<commit_message>
Fix evaluation integrity: break detector circularity, add real ablation
- Offline agent is now a naive narrative-truster (obeys injections AND believes
  stated reasons), so an attack can succeed with no injection to detect. The
  firewall's win now comes from L3 checking facts, not from a detector matching
  its own trigger words.
- Adjudication-gaming attacks rewritten as false factual claims; now a real
  offline threat (100% unguarded), demonstrating why L3 is needed.
- Replaced misleading blocked_by counts with a real layer ablation:
  no-fw 83.3%, detection-only 6.7%, adjudication-only 0%, full 0%.
- Removed dead _breach(); parametrised firewall layers; updated console demo,
  charts, deck, README, writeup, and LIMITATIONS to match.
</commit_message>
<xml_diff>
--- a/submission/Sentinel_Deck.pptx
+++ b/submission/Sentinel_Deck.pptx
@@ -3852,7 +3852,7 @@
         <p:spPr>
           <a:xfrm>
             <a:off x="640080" y="2194560"/>
-            <a:ext cx="5852160" cy="4023360"/>
+            <a:ext cx="6472362" cy="4023360"/>
           </a:xfrm>
           <a:prstGeom prst="rect">
             <a:avLst/>
@@ -3889,7 +3889,7 @@
                 </a:solidFill>
                 <a:latin typeface="Calibri"/>
               </a:rPr>
-              <a:t>Detection (L2) stops the loud attacks. But L3 is the backstop that holds when detection misses — including attacks with nothing to detect.</a:t>
+              <a:t>Detection alone still leaks 6.7% — the false-claim attacks with no injection to catch. Layer 3, deciding on verified bank facts, closes it. Necessary and sufficient; the rest is defence-in-depth.</a:t>
             </a:r>
           </a:p>
         </p:txBody>
@@ -8562,7 +8562,7 @@
                 </a:solidFill>
                 <a:latin typeface="Cambria"/>
               </a:rPr>
-              <a:t>66.7% of attacks succeed. With Sentinel, 0%.</a:t>
+              <a:t>83.3% of attacks succeed. With Sentinel, 0%.</a:t>
             </a:r>
           </a:p>
         </p:txBody>
@@ -8621,7 +8621,7 @@
                 </a:solidFill>
                 <a:latin typeface="Cambria"/>
               </a:rPr>
-              <a:t>66.7%</a:t>
+              <a:t>83.3%</a:t>
             </a:r>
           </a:p>
         </p:txBody>

</xml_diff>

<commit_message>
Add beat-the-obvious-defence baseline (hardened prompt)
Answers the top judge question 'why not just harden the system prompt?'.
Measured: no defence 83.3%, hardened prompt 16.7% (fails 100% on adjudication
gaming), Sentinel 0%. Adds eval/baselines.py, chart4, and a deck slide;
updates README + writeup. Proves Sentinel is a structural control, not a
prompt band-aid.
</commit_message>
<xml_diff>
--- a/submission/Sentinel_Deck.pptx
+++ b/submission/Sentinel_Deck.pptx
@@ -17,6 +17,7 @@
     <p:sldId id="265" r:id="rId17"/>
     <p:sldId id="266" r:id="rId18"/>
     <p:sldId id="267" r:id="rId19"/>
+    <p:sldId id="268" r:id="rId20"/>
   </p:sldIdLst>
   <p:sldSz cx="12161520" cy="6858000" type="screen4x3"/>
   <p:notesSz cx="6858000" cy="9144000"/>
@@ -3986,6 +3987,208 @@
                 </a:solidFill>
                 <a:latin typeface="Calibri"/>
               </a:rPr>
+              <a:t>RIGOR</a:t>
+            </a:r>
+          </a:p>
+        </p:txBody>
+      </p:sp>
+      <p:sp>
+        <p:nvSpPr>
+          <p:cNvPr id="4" name="TextBox 3"/>
+          <p:cNvSpPr txBox="1"/>
+          <p:nvPr/>
+        </p:nvSpPr>
+        <p:spPr>
+          <a:xfrm>
+            <a:off x="548640" y="822960"/>
+            <a:ext cx="11064240" cy="1097280"/>
+          </a:xfrm>
+          <a:prstGeom prst="rect">
+            <a:avLst/>
+          </a:prstGeom>
+          <a:noFill/>
+        </p:spPr>
+        <p:txBody>
+          <a:bodyPr wrap="square" anchor="t" lIns="0" rIns="0" tIns="0" bIns="0">
+            <a:spAutoFit/>
+          </a:bodyPr>
+          <a:lstStyle/>
+          <a:p>
+            <a:pPr algn="l"/>
+            <a:r>
+              <a:rPr sz="3200" b="1" i="0">
+                <a:solidFill>
+                  <a:srgbClr val="E9ECF3"/>
+                </a:solidFill>
+                <a:latin typeface="Cambria"/>
+              </a:rPr>
+              <a:t>We beat the obvious defence</a:t>
+            </a:r>
+          </a:p>
+        </p:txBody>
+      </p:sp>
+      <p:sp>
+        <p:nvSpPr>
+          <p:cNvPr id="5" name="TextBox 4"/>
+          <p:cNvSpPr txBox="1"/>
+          <p:nvPr/>
+        </p:nvSpPr>
+        <p:spPr>
+          <a:xfrm>
+            <a:off x="6766560" y="1737360"/>
+            <a:ext cx="4846320" cy="822960"/>
+          </a:xfrm>
+          <a:prstGeom prst="rect">
+            <a:avLst/>
+          </a:prstGeom>
+          <a:noFill/>
+        </p:spPr>
+        <p:txBody>
+          <a:bodyPr wrap="square" anchor="t" lIns="0" rIns="0" tIns="0" bIns="0">
+            <a:spAutoFit/>
+          </a:bodyPr>
+          <a:lstStyle/>
+          <a:p>
+            <a:pPr algn="l"/>
+            <a:r>
+              <a:rPr sz="1600" b="0" i="0">
+                <a:solidFill>
+                  <a:srgbClr val="E9ECF3"/>
+                </a:solidFill>
+                <a:latin typeface="Calibri"/>
+              </a:rPr>
+              <a:t>“Why not just harden the system prompt?” We built that baseline and measured it.</a:t>
+            </a:r>
+          </a:p>
+        </p:txBody>
+      </p:sp>
+      <p:sp>
+        <p:nvSpPr>
+          <p:cNvPr id="6" name="TextBox 5"/>
+          <p:cNvSpPr txBox="1"/>
+          <p:nvPr/>
+        </p:nvSpPr>
+        <p:spPr>
+          <a:xfrm>
+            <a:off x="6766560" y="2743200"/>
+            <a:ext cx="4846320" cy="2377440"/>
+          </a:xfrm>
+          <a:prstGeom prst="rect">
+            <a:avLst/>
+          </a:prstGeom>
+          <a:noFill/>
+        </p:spPr>
+        <p:txBody>
+          <a:bodyPr wrap="square" anchor="t" lIns="0" rIns="0" tIns="0" bIns="0">
+            <a:spAutoFit/>
+          </a:bodyPr>
+          <a:lstStyle/>
+          <a:p>
+            <a:pPr algn="l"/>
+            <a:r>
+              <a:rPr sz="1500" b="0" i="0">
+                <a:solidFill>
+                  <a:srgbClr val="E9ECF3"/>
+                </a:solidFill>
+                <a:latin typeface="Calibri"/>
+              </a:rPr>
+              <a:t>Prompt-hardening cuts attacks 83.3% → 16.7% — but fails 100% on adjudication gaming. A customer lying about the facts is not an injection. Only checking the bank's records (Layer 3) reaches 0%. Structural control, not a prompt band-aid.</a:t>
+            </a:r>
+          </a:p>
+        </p:txBody>
+      </p:sp>
+    </p:spTree>
+  </p:cSld>
+  <p:clrMapOvr>
+    <a:masterClrMapping/>
+  </p:clrMapOvr>
+</p:sld>
+</file>
+
+<file path=ppt/slides/slide12.xml><?xml version="1.0" encoding="utf-8"?>
+<p:sld xmlns:a="http://schemas.openxmlformats.org/drawingml/2006/main" xmlns:p="http://schemas.openxmlformats.org/presentationml/2006/main" xmlns:r="http://schemas.openxmlformats.org/officeDocument/2006/relationships">
+  <p:cSld>
+    <p:spTree>
+      <p:nvGrpSpPr>
+        <p:cNvPr id="1" name=""/>
+        <p:cNvGrpSpPr/>
+        <p:nvPr/>
+      </p:nvGrpSpPr>
+      <p:grpSpPr/>
+      <p:sp>
+        <p:nvSpPr>
+          <p:cNvPr id="2" name="Rectangle 1"/>
+          <p:cNvSpPr/>
+          <p:nvPr/>
+        </p:nvSpPr>
+        <p:spPr>
+          <a:xfrm>
+            <a:off x="0" y="0"/>
+            <a:ext cx="12161520" cy="6858000"/>
+          </a:xfrm>
+          <a:prstGeom prst="rect">
+            <a:avLst/>
+          </a:prstGeom>
+          <a:solidFill>
+            <a:srgbClr val="12151D"/>
+          </a:solidFill>
+          <a:ln>
+            <a:noFill/>
+          </a:ln>
+          <a:effectLst/>
+        </p:spPr>
+        <p:style>
+          <a:lnRef idx="1">
+            <a:schemeClr val="accent1"/>
+          </a:lnRef>
+          <a:fillRef idx="3">
+            <a:schemeClr val="accent1"/>
+          </a:fillRef>
+          <a:effectRef idx="2">
+            <a:schemeClr val="accent1"/>
+          </a:effectRef>
+          <a:fontRef idx="minor">
+            <a:schemeClr val="lt1"/>
+          </a:fontRef>
+        </p:style>
+        <p:txBody>
+          <a:bodyPr rtlCol="0" anchor="ctr"/>
+          <a:lstStyle/>
+          <a:p>
+            <a:pPr algn="ctr"/>
+          </a:p>
+        </p:txBody>
+      </p:sp>
+      <p:sp>
+        <p:nvSpPr>
+          <p:cNvPr id="3" name="TextBox 2"/>
+          <p:cNvSpPr txBox="1"/>
+          <p:nvPr/>
+        </p:nvSpPr>
+        <p:spPr>
+          <a:xfrm>
+            <a:off x="548640" y="411480"/>
+            <a:ext cx="9144000" cy="320040"/>
+          </a:xfrm>
+          <a:prstGeom prst="rect">
+            <a:avLst/>
+          </a:prstGeom>
+          <a:noFill/>
+        </p:spPr>
+        <p:txBody>
+          <a:bodyPr wrap="square" anchor="t" lIns="0" rIns="0" tIns="0" bIns="0">
+            <a:spAutoFit/>
+          </a:bodyPr>
+          <a:lstStyle/>
+          <a:p>
+            <a:pPr algn="l"/>
+            <a:r>
+              <a:rPr sz="1100" b="1" i="0">
+                <a:solidFill>
+                  <a:srgbClr val="E0BE55"/>
+                </a:solidFill>
+                <a:latin typeface="Calibri"/>
+              </a:rPr>
               <a:t>WHY MASTERCARD</a:t>
             </a:r>
           </a:p>
@@ -4301,7 +4504,7 @@
 </p:sld>
 </file>
 
-<file path=ppt/slides/slide12.xml><?xml version="1.0" encoding="utf-8"?>
+<file path=ppt/slides/slide13.xml><?xml version="1.0" encoding="utf-8"?>
 <p:sld xmlns:a="http://schemas.openxmlformats.org/drawingml/2006/main" xmlns:p="http://schemas.openxmlformats.org/presentationml/2006/main" xmlns:r="http://schemas.openxmlformats.org/officeDocument/2006/relationships">
   <p:cSld>
     <p:spTree>

</xml_diff>